<commit_message>
Web de la consultora: 8 idiomas (es, en, pt, fr, de, it, ar, zh) y mercados sin límite de países
- Textos en src/lang/*.php con respaldo en español; detección del idioma del navegador y selector
- Árabe de derecha a izquierda, fuentes para árabe y chino
- Inicio con regiones del mundo en lugar de una lista de 4 países; formulario con mercado de interés
- Ingreso con Google para cualquier país; DNI solo para clientes de Argentina
- Presentación y documento de cultura actualizados; pruebas ampliadas

Co-Authored-By: Claude Sonnet 5.5 <noreply@anthropic.com>
</commit_message>
<xml_diff>
--- a/02_Presentaciones/01_Presentacion_Consultora_RumboGlobal.pptx
+++ b/02_Presentaciones/01_Presentacion_Consultora_RumboGlobal.pptx
@@ -4547,13 +4547,13 @@
               </a:spcAft>
             </a:pPr>
             <a:r>
-              <a:rPr sz="5400" b="1" i="0">
+              <a:rPr sz="2400" b="1" i="0">
                 <a:solidFill>
                   <a:srgbClr val="D0021B"/>
                 </a:solidFill>
                 <a:latin typeface="Arial"/>
               </a:rPr>
-              <a:t>4</a:t>
+              <a:t>Mundo</a:t>
             </a:r>
           </a:p>
         </p:txBody>
@@ -4595,7 +4595,7 @@
                 </a:solidFill>
                 <a:latin typeface="Calibri"/>
               </a:rPr>
-              <a:t>países de Medio Oriente en nuestro proyecto actual</a:t>
+              <a:t>sin límite de países: cada proyecto elige su mercado</a:t>
             </a:r>
           </a:p>
         </p:txBody>
@@ -4809,7 +4809,7 @@
                 </a:solidFill>
                 <a:latin typeface="Arial"/>
               </a:rPr>
-              <a:t>3</a:t>
+              <a:t>8</a:t>
             </a:r>
           </a:p>
         </p:txBody>
@@ -4851,7 +4851,7 @@
                 </a:solidFill>
                 <a:latin typeface="Calibri"/>
               </a:rPr>
-              <a:t>idiomas de trabajo: español, inglés y árabe</a:t>
+              <a:t>idiomas en nuestro sitio web</a:t>
             </a:r>
           </a:p>
         </p:txBody>

</xml_diff>